<commit_message>
Slides: fix review findings in sd-06-016, 017, 020, 022
sd-06-016: add the SIEM use case to slide 6.
sd-06-017: add the content-delivery slide (edge, regional tier, origin); deck is now 9 slides.
sd-06-020: qualify the list-queue limit as a simple list queue.
sd-06-022: put shards in the Elasticsearch layer on slide 2.
PPTX files re-exported.

Co-Authored-By: Claude Sonnet 5.5 <noreply@anthropic.com>
Claude-Session: https://claude.ai/code/session_01LZTvSvg7XFAbom38DqwJ6J
</commit_message>
<xml_diff>
--- a/system-design-101/vi/lessons/sd-06-016/slides/sd-06-016.pptx
+++ b/system-design-101/vi/lessons/sd-06-016/slides/sd-06-016.pptx
@@ -11057,7 +11057,7 @@
               <a:buNone/>
             </a:pPr>
             <a:r>
-              <a:rPr lang="en-US" sz="7500" dirty="0" spc="-7" kern="0">
+              <a:rPr lang="en-US" sz="7500" dirty="0" spc="3" kern="0">
                 <a:solidFill>
                   <a:srgbClr val="F3EEE3"/>
                 </a:solidFill>
@@ -11065,7 +11065,7 @@
                 <a:ea typeface="Bricolage Grotesque ExtraBold" pitchFamily="34" charset="-122"/>
                 <a:cs typeface="Bricolage Grotesque ExtraBold" pitchFamily="34" charset="-120"/>
               </a:rPr>
-              <a:t>Job</a:t>
+              <a:t>Học</a:t>
             </a:r>
             <a:r>
               <a:rPr lang="en-US" sz="7500" dirty="0" spc="2" kern="0">
@@ -11076,10 +11076,10 @@
                 <a:ea typeface="Bricolage Grotesque ExtraBold" pitchFamily="34" charset="-122"/>
                 <a:cs typeface="Bricolage Grotesque ExtraBold" pitchFamily="34" charset="-120"/>
               </a:rPr>
-              <a:t> học máy</a:t>
-            </a:r>
-            <a:r>
-              <a:rPr lang="en-US" sz="7500" dirty="0" spc="-1" kern="0">
+              <a:t> máy</a:t>
+            </a:r>
+            <a:r>
+              <a:rPr lang="en-US" sz="7500" dirty="0" spc="-81" kern="0">
                 <a:solidFill>
                   <a:srgbClr val="F3EEE3"/>
                 </a:solidFill>
@@ -11087,10 +11087,10 @@
                 <a:ea typeface="Bricolage Grotesque ExtraBold" pitchFamily="34" charset="-122"/>
                 <a:cs typeface="Bricolage Grotesque ExtraBold" pitchFamily="34" charset="-120"/>
               </a:rPr>
-              <a:t> bị</a:t>
-            </a:r>
-            <a:r>
-              <a:rPr lang="en-US" sz="7500" dirty="0" spc="-2" kern="0">
+              <a:t> và</a:t>
+            </a:r>
+            <a:r>
+              <a:rPr lang="en-US" sz="7500" dirty="0" spc="-1" kern="0">
                 <a:solidFill>
                   <a:srgbClr val="F3EEE3"/>
                 </a:solidFill>
@@ -11098,7 +11098,7 @@
                 <a:ea typeface="Bricolage Grotesque ExtraBold" pitchFamily="34" charset="-122"/>
                 <a:cs typeface="Bricolage Grotesque ExtraBold" pitchFamily="34" charset="-120"/>
               </a:rPr>
-              <a:t> từ</a:t>
+              <a:t> an</a:t>
             </a:r>
             <a:r>
               <a:rPr lang="en-US" sz="7500" dirty="0" spc="2" kern="0">
@@ -11109,7 +11109,7 @@
                 <a:ea typeface="Bricolage Grotesque ExtraBold" pitchFamily="34" charset="-122"/>
                 <a:cs typeface="Bricolage Grotesque ExtraBold" pitchFamily="34" charset="-120"/>
               </a:rPr>
-              <a:t> chối</a:t>
+              <a:t> ninh</a:t>
             </a:r>
             <a:endParaRPr lang="en-US" sz="7500" dirty="0"/>
           </a:p>
@@ -11123,8 +11123,8 @@
         </p:nvSpPr>
         <p:spPr>
           <a:xfrm>
-            <a:off x="914400" y="3048000"/>
-            <a:ext cx="133350" cy="2857500"/>
+            <a:off x="914400" y="2857500"/>
+            <a:ext cx="133350" cy="2381250"/>
           </a:xfrm>
           <a:prstGeom prst="roundRect">
             <a:avLst>
@@ -11145,8 +11145,8 @@
         </p:nvSpPr>
         <p:spPr>
           <a:xfrm>
-            <a:off x="1428750" y="2952750"/>
-            <a:ext cx="15716250" cy="3143250"/>
+            <a:off x="1428750" y="2762250"/>
+            <a:ext cx="15716250" cy="2667000"/>
           </a:xfrm>
           <a:prstGeom prst="rect">
             <a:avLst/>
@@ -11155,17 +11155,17 @@
           <a:ln/>
         </p:spPr>
         <p:txBody>
-          <a:bodyPr wrap="square" lIns="0" tIns="45720" rIns="0" bIns="-45720" rtlCol="0" anchor="t"/>
+          <a:bodyPr wrap="square" lIns="0" tIns="40005" rIns="0" bIns="-40005" rtlCol="0" anchor="t"/>
           <a:lstStyle/>
           <a:p>
             <a:pPr algn="l" indent="0" marL="0">
               <a:lnSpc>
-                <a:spcPts val="7920"/>
+                <a:spcPts val="6930"/>
               </a:lnSpc>
               <a:buNone/>
             </a:pPr>
             <a:r>
-              <a:rPr lang="en-US" sz="7200" dirty="0" spc="-43" kern="0">
+              <a:rPr lang="en-US" sz="6300" dirty="0" spc="-42" kern="0">
                 <a:solidFill>
                   <a:srgbClr val="FF6A4D"/>
                 </a:solidFill>
@@ -11176,7 +11176,7 @@
               <a:t>“current</a:t>
             </a:r>
             <a:r>
-              <a:rPr lang="en-US" sz="7200" dirty="0" spc="2" kern="0">
+              <a:rPr lang="en-US" sz="6300" dirty="0" spc="0" kern="0">
                 <a:solidFill>
                   <a:srgbClr val="FF6A4D"/>
                 </a:solidFill>
@@ -11184,10 +11184,10 @@
                 <a:ea typeface="Bricolage Grotesque ExtraBold" pitchFamily="34" charset="-122"/>
                 <a:cs typeface="Bricolage Grotesque ExtraBold" pitchFamily="34" charset="-120"/>
               </a:rPr>
-              <a:t> license</a:t>
-            </a:r>
-            <a:r>
-              <a:rPr lang="en-US" sz="7200" dirty="0" spc="-3" kern="0">
+              <a:t> license is</a:t>
+            </a:r>
+            <a:r>
+              <a:rPr lang="en-US" sz="6300" dirty="0" spc="7" kern="0">
                 <a:solidFill>
                   <a:srgbClr val="FF6A4D"/>
                 </a:solidFill>
@@ -11195,10 +11195,10 @@
                 <a:ea typeface="Bricolage Grotesque ExtraBold" pitchFamily="34" charset="-122"/>
                 <a:cs typeface="Bricolage Grotesque ExtraBold" pitchFamily="34" charset="-120"/>
               </a:rPr>
-              <a:t> is</a:t>
-            </a:r>
-            <a:r>
-              <a:rPr lang="en-US" sz="7200" dirty="0" spc="6" kern="0">
+              <a:t> non-compliant</a:t>
+            </a:r>
+            <a:r>
+              <a:rPr lang="en-US" sz="6300" dirty="0" spc="-12" kern="0">
                 <a:solidFill>
                   <a:srgbClr val="FF6A4D"/>
                 </a:solidFill>
@@ -11206,10 +11206,10 @@
                 <a:ea typeface="Bricolage Grotesque ExtraBold" pitchFamily="34" charset="-122"/>
                 <a:cs typeface="Bricolage Grotesque ExtraBold" pitchFamily="34" charset="-120"/>
               </a:rPr>
-              <a:t> non-compliant</a:t>
-            </a:r>
-            <a:r>
-              <a:rPr lang="en-US" sz="7200" dirty="0" spc="-13" kern="0">
+              <a:t> for</a:t>
+            </a:r>
+            <a:r>
+              <a:rPr lang="en-US" sz="6300" dirty="0" spc="-29" kern="0">
                 <a:solidFill>
                   <a:srgbClr val="FF6A4D"/>
                 </a:solidFill>
@@ -11217,20 +11217,9 @@
                 <a:ea typeface="Bricolage Grotesque ExtraBold" pitchFamily="34" charset="-122"/>
                 <a:cs typeface="Bricolage Grotesque ExtraBold" pitchFamily="34" charset="-120"/>
               </a:rPr>
-              <a:t> for</a:t>
-            </a:r>
-            <a:r>
-              <a:rPr lang="en-US" sz="7200" dirty="0" spc="-33" kern="0">
-                <a:solidFill>
-                  <a:srgbClr val="FF6A4D"/>
-                </a:solidFill>
-                <a:latin typeface="Bricolage Grotesque ExtraBold" pitchFamily="34" charset="0"/>
-                <a:ea typeface="Bricolage Grotesque ExtraBold" pitchFamily="34" charset="-122"/>
-                <a:cs typeface="Bricolage Grotesque ExtraBold" pitchFamily="34" charset="-120"/>
-              </a:rPr>
               <a:t> [ml]”</a:t>
             </a:r>
-            <a:endParaRPr lang="en-US" sz="7200" dirty="0"/>
+            <a:endParaRPr lang="en-US" sz="6300" dirty="0"/>
           </a:p>
         </p:txBody>
       </p:sp>
@@ -11242,7 +11231,7 @@
         </p:nvSpPr>
         <p:spPr>
           <a:xfrm>
-            <a:off x="914400" y="7048500"/>
+            <a:off x="914400" y="5905500"/>
             <a:ext cx="4381500" cy="762000"/>
           </a:xfrm>
           <a:prstGeom prst="roundRect">
@@ -11295,13 +11284,13 @@
       </p:sp>
       <p:sp>
         <p:nvSpPr>
-          <p:cNvPr id="7" name="Connector line-1792441416774-723604663"/>
-          <p:cNvSpPr/>
-          <p:nvPr/>
-        </p:nvSpPr>
-        <p:spPr>
-          <a:xfrm>
-            <a:off x="5524500" y="7429500"/>
+          <p:cNvPr id="7" name="Connector line-1792442910581-491481936"/>
+          <p:cNvSpPr/>
+          <p:nvPr/>
+        </p:nvSpPr>
+        <p:spPr>
+          <a:xfrm>
+            <a:off x="5524500" y="6286500"/>
             <a:ext cx="952500" cy="0"/>
           </a:xfrm>
           <a:prstGeom prst="line">
@@ -11326,7 +11315,7 @@
         </p:nvSpPr>
         <p:spPr>
           <a:xfrm>
-            <a:off x="6667500" y="7048500"/>
+            <a:off x="6667500" y="5905500"/>
             <a:ext cx="6667500" cy="762000"/>
           </a:xfrm>
           <a:prstGeom prst="roundRect">
@@ -11429,7 +11418,7 @@
         </p:nvSpPr>
         <p:spPr>
           <a:xfrm>
-            <a:off x="13620750" y="7143750"/>
+            <a:off x="13620750" y="6000750"/>
             <a:ext cx="3810000" cy="571500"/>
           </a:xfrm>
           <a:prstGeom prst="rect">
@@ -11490,258 +11479,30 @@
         </p:nvSpPr>
         <p:spPr>
           <a:xfrm>
-            <a:off x="933450" y="9429750"/>
-            <a:ext cx="114300" cy="114300"/>
-          </a:xfrm>
-          <a:prstGeom prst="ellipse">
-            <a:avLst/>
-          </a:prstGeom>
-          <a:solidFill>
-            <a:srgbClr val="F3EEE3"/>
-          </a:solidFill>
-          <a:ln w="19050">
-            <a:solidFill>
-              <a:srgbClr val="F3EEE3"/>
-            </a:solidFill>
-            <a:prstDash val="solid"/>
-          </a:ln>
-        </p:spPr>
-      </p:sp>
-      <p:sp>
-        <p:nvSpPr>
-          <p:cNvPr id="11" name="Shape 9"/>
-          <p:cNvSpPr/>
-          <p:nvPr/>
-        </p:nvSpPr>
-        <p:spPr>
-          <a:xfrm>
-            <a:off x="1262063" y="9429750"/>
-            <a:ext cx="114300" cy="114300"/>
-          </a:xfrm>
-          <a:prstGeom prst="ellipse">
-            <a:avLst/>
-          </a:prstGeom>
-          <a:solidFill>
-            <a:srgbClr val="F3EEE3"/>
-          </a:solidFill>
-          <a:ln w="19050">
-            <a:solidFill>
-              <a:srgbClr val="F3EEE3"/>
-            </a:solidFill>
-            <a:prstDash val="solid"/>
-          </a:ln>
-        </p:spPr>
-      </p:sp>
-      <p:sp>
-        <p:nvSpPr>
-          <p:cNvPr id="12" name="Shape 10"/>
-          <p:cNvSpPr/>
-          <p:nvPr/>
-        </p:nvSpPr>
-        <p:spPr>
-          <a:xfrm>
-            <a:off x="1590675" y="9429750"/>
-            <a:ext cx="114300" cy="114300"/>
-          </a:xfrm>
-          <a:prstGeom prst="ellipse">
-            <a:avLst/>
-          </a:prstGeom>
-          <a:solidFill>
-            <a:srgbClr val="F3EEE3"/>
-          </a:solidFill>
-          <a:ln w="19050">
-            <a:solidFill>
-              <a:srgbClr val="F3EEE3"/>
-            </a:solidFill>
-            <a:prstDash val="solid"/>
-          </a:ln>
-        </p:spPr>
-      </p:sp>
-      <p:sp>
-        <p:nvSpPr>
-          <p:cNvPr id="13" name="Shape 11"/>
-          <p:cNvSpPr/>
-          <p:nvPr/>
-        </p:nvSpPr>
-        <p:spPr>
-          <a:xfrm>
-            <a:off x="1919288" y="9429750"/>
-            <a:ext cx="114300" cy="114300"/>
-          </a:xfrm>
-          <a:prstGeom prst="ellipse">
-            <a:avLst/>
-          </a:prstGeom>
-          <a:solidFill>
-            <a:srgbClr val="F3EEE3"/>
-          </a:solidFill>
-          <a:ln w="19050">
-            <a:solidFill>
-              <a:srgbClr val="F3EEE3"/>
-            </a:solidFill>
-            <a:prstDash val="solid"/>
-          </a:ln>
-        </p:spPr>
-      </p:sp>
-      <p:sp>
-        <p:nvSpPr>
-          <p:cNvPr id="14" name="Shape 12"/>
-          <p:cNvSpPr/>
-          <p:nvPr/>
-        </p:nvSpPr>
-        <p:spPr>
-          <a:xfrm>
-            <a:off x="2247900" y="9429750"/>
-            <a:ext cx="114300" cy="114300"/>
-          </a:xfrm>
-          <a:prstGeom prst="ellipse">
-            <a:avLst/>
-          </a:prstGeom>
-          <a:solidFill>
-            <a:srgbClr val="F3EEE3"/>
-          </a:solidFill>
-          <a:ln w="19050">
-            <a:solidFill>
-              <a:srgbClr val="F3EEE3"/>
-            </a:solidFill>
-            <a:prstDash val="solid"/>
-          </a:ln>
-        </p:spPr>
-      </p:sp>
-      <p:sp>
-        <p:nvSpPr>
-          <p:cNvPr id="15" name="Shape 13"/>
-          <p:cNvSpPr/>
-          <p:nvPr/>
-        </p:nvSpPr>
-        <p:spPr>
-          <a:xfrm>
-            <a:off x="2528888" y="9382125"/>
-            <a:ext cx="209550" cy="209550"/>
-          </a:xfrm>
-          <a:prstGeom prst="ellipse">
-            <a:avLst/>
-          </a:prstGeom>
-          <a:solidFill>
-            <a:srgbClr val="FF6A4D"/>
-          </a:solidFill>
-          <a:ln w="19050">
-            <a:solidFill>
-              <a:srgbClr val="FF6A4D"/>
-            </a:solidFill>
-            <a:prstDash val="solid"/>
-          </a:ln>
-        </p:spPr>
-      </p:sp>
-      <p:sp>
-        <p:nvSpPr>
-          <p:cNvPr id="16" name="Shape 14"/>
-          <p:cNvSpPr/>
-          <p:nvPr/>
-        </p:nvSpPr>
-        <p:spPr>
-          <a:xfrm>
-            <a:off x="2905125" y="9429750"/>
-            <a:ext cx="114300" cy="114300"/>
-          </a:xfrm>
-          <a:prstGeom prst="ellipse">
-            <a:avLst/>
-          </a:prstGeom>
-          <a:solidFill>
-            <a:srgbClr val="14161C"/>
-          </a:solidFill>
-          <a:ln w="19050">
-            <a:solidFill>
-              <a:srgbClr val="F3EEE3"/>
-            </a:solidFill>
-            <a:prstDash val="solid"/>
-          </a:ln>
-        </p:spPr>
-      </p:sp>
-      <p:sp>
-        <p:nvSpPr>
-          <p:cNvPr id="17" name="Shape 15"/>
-          <p:cNvSpPr/>
-          <p:nvPr/>
-        </p:nvSpPr>
-        <p:spPr>
-          <a:xfrm>
-            <a:off x="3233738" y="9429750"/>
-            <a:ext cx="114300" cy="114300"/>
-          </a:xfrm>
-          <a:prstGeom prst="ellipse">
-            <a:avLst/>
-          </a:prstGeom>
-          <a:solidFill>
-            <a:srgbClr val="14161C"/>
-          </a:solidFill>
-          <a:ln w="19050">
-            <a:solidFill>
-              <a:srgbClr val="F3EEE3"/>
-            </a:solidFill>
-            <a:prstDash val="solid"/>
-          </a:ln>
-        </p:spPr>
-      </p:sp>
-      <p:sp>
-        <p:nvSpPr>
-          <p:cNvPr id="18" name="Shape 16"/>
-          <p:cNvSpPr/>
-          <p:nvPr/>
-        </p:nvSpPr>
-        <p:spPr>
-          <a:xfrm>
-            <a:off x="3562350" y="9429750"/>
-            <a:ext cx="114300" cy="114300"/>
-          </a:xfrm>
-          <a:prstGeom prst="ellipse">
-            <a:avLst/>
-          </a:prstGeom>
-          <a:solidFill>
-            <a:srgbClr val="14161C"/>
-          </a:solidFill>
-          <a:ln w="19050">
-            <a:solidFill>
-              <a:srgbClr val="F3EEE3"/>
-            </a:solidFill>
-            <a:prstDash val="solid"/>
-          </a:ln>
-        </p:spPr>
-      </p:sp>
-      <p:sp>
-        <p:nvSpPr>
-          <p:cNvPr id="19" name="Shape 17"/>
-          <p:cNvSpPr/>
-          <p:nvPr/>
-        </p:nvSpPr>
-        <p:spPr>
-          <a:xfrm>
-            <a:off x="3890962" y="9429750"/>
-            <a:ext cx="114300" cy="114300"/>
-          </a:xfrm>
-          <a:prstGeom prst="ellipse">
-            <a:avLst/>
-          </a:prstGeom>
-          <a:solidFill>
-            <a:srgbClr val="14161C"/>
-          </a:solidFill>
-          <a:ln w="19050">
-            <a:solidFill>
-              <a:srgbClr val="F3EEE3"/>
-            </a:solidFill>
-            <a:prstDash val="solid"/>
-          </a:ln>
-        </p:spPr>
-      </p:sp>
-      <p:sp>
-        <p:nvSpPr>
-          <p:cNvPr id="20" name="Text 18"/>
-          <p:cNvSpPr/>
-          <p:nvPr/>
-        </p:nvSpPr>
-        <p:spPr>
-          <a:xfrm>
-            <a:off x="914400" y="9715500"/>
-            <a:ext cx="7620000" cy="285750"/>
+            <a:off x="914400" y="7334250"/>
+            <a:ext cx="16459200" cy="1238250"/>
+          </a:xfrm>
+          <a:prstGeom prst="roundRect">
+            <a:avLst>
+              <a:gd name="adj" fmla="val 20000"/>
+            </a:avLst>
+          </a:prstGeom>
+          <a:solidFill>
+            <a:srgbClr val="1E212B"/>
+          </a:solidFill>
+          <a:ln/>
+        </p:spPr>
+      </p:sp>
+      <p:sp>
+        <p:nvSpPr>
+          <p:cNvPr id="11" name="Text 9"/>
+          <p:cNvSpPr/>
+          <p:nvPr/>
+        </p:nvSpPr>
+        <p:spPr>
+          <a:xfrm>
+            <a:off x="1295400" y="7581900"/>
+            <a:ext cx="3810000" cy="381000"/>
           </a:xfrm>
           <a:prstGeom prst="rect">
             <a:avLst/>
@@ -11757,6 +11518,466 @@
               <a:buNone/>
             </a:pPr>
             <a:r>
+              <a:rPr lang="en-US" sz="1800" b="1" spc="225" kern="0" dirty="0">
+                <a:solidFill>
+                  <a:srgbClr val="FF6A4D"/>
+                </a:solidFill>
+                <a:latin typeface="Be Vietnam Pro" pitchFamily="34" charset="0"/>
+                <a:ea typeface="Be Vietnam Pro" pitchFamily="34" charset="-122"/>
+                <a:cs typeface="Be Vietnam Pro" pitchFamily="34" charset="-120"/>
+              </a:rPr>
+              <a:t>SIEM</a:t>
+            </a:r>
+            <a:endParaRPr lang="en-US" sz="1800" dirty="0"/>
+          </a:p>
+        </p:txBody>
+      </p:sp>
+      <p:sp>
+        <p:nvSpPr>
+          <p:cNvPr id="12" name="Text 10"/>
+          <p:cNvSpPr/>
+          <p:nvPr/>
+        </p:nvSpPr>
+        <p:spPr>
+          <a:xfrm>
+            <a:off x="1295400" y="8020050"/>
+            <a:ext cx="15716250" cy="476250"/>
+          </a:xfrm>
+          <a:prstGeom prst="rect">
+            <a:avLst/>
+          </a:prstGeom>
+          <a:noFill/>
+          <a:ln/>
+        </p:spPr>
+        <p:txBody>
+          <a:bodyPr wrap="square" lIns="0" tIns="0" rIns="0" bIns="0" rtlCol="0" anchor="ctr"/>
+          <a:lstStyle/>
+          <a:p>
+            <a:pPr algn="l" indent="0" marL="0">
+              <a:buNone/>
+            </a:pPr>
+            <a:r>
+              <a:rPr lang="en-US" sz="2550" dirty="0" spc="-3" kern="0">
+                <a:solidFill>
+                  <a:srgbClr val="F3EEE3"/>
+                </a:solidFill>
+                <a:latin typeface="Be Vietnam Pro" pitchFamily="34" charset="0"/>
+                <a:ea typeface="Be Vietnam Pro" pitchFamily="34" charset="-122"/>
+                <a:cs typeface="Be Vietnam Pro" pitchFamily="34" charset="-120"/>
+              </a:rPr>
+              <a:t>Elastic</a:t>
+            </a:r>
+            <a:r>
+              <a:rPr lang="en-US" sz="2550" dirty="0" spc="2" kern="0">
+                <a:solidFill>
+                  <a:srgbClr val="F3EEE3"/>
+                </a:solidFill>
+                <a:latin typeface="Be Vietnam Pro" pitchFamily="34" charset="0"/>
+                <a:ea typeface="Be Vietnam Pro" pitchFamily="34" charset="-122"/>
+                <a:cs typeface="Be Vietnam Pro" pitchFamily="34" charset="-120"/>
+              </a:rPr>
+              <a:t> Security:</a:t>
+            </a:r>
+            <a:r>
+              <a:rPr lang="en-US" sz="2550" dirty="0" spc="19" kern="0">
+                <a:solidFill>
+                  <a:srgbClr val="F3EEE3"/>
+                </a:solidFill>
+                <a:latin typeface="Be Vietnam Pro" pitchFamily="34" charset="0"/>
+                <a:ea typeface="Be Vietnam Pro" pitchFamily="34" charset="-122"/>
+                <a:cs typeface="Be Vietnam Pro" pitchFamily="34" charset="-120"/>
+              </a:rPr>
+              <a:t> dựng</a:t>
+            </a:r>
+            <a:r>
+              <a:rPr lang="en-US" sz="2550" dirty="0" spc="-19" kern="0">
+                <a:solidFill>
+                  <a:srgbClr val="F3EEE3"/>
+                </a:solidFill>
+                <a:latin typeface="Be Vietnam Pro" pitchFamily="34" charset="0"/>
+                <a:ea typeface="Be Vietnam Pro" pitchFamily="34" charset="-122"/>
+                <a:cs typeface="Be Vietnam Pro" pitchFamily="34" charset="-120"/>
+              </a:rPr>
+              <a:t> trên</a:t>
+            </a:r>
+            <a:r>
+              <a:rPr lang="en-US" sz="2550" dirty="0" spc="-12" kern="0">
+                <a:solidFill>
+                  <a:srgbClr val="F3EEE3"/>
+                </a:solidFill>
+                <a:latin typeface="Be Vietnam Pro" pitchFamily="34" charset="0"/>
+                <a:ea typeface="Be Vietnam Pro" pitchFamily="34" charset="-122"/>
+                <a:cs typeface="Be Vietnam Pro" pitchFamily="34" charset="-120"/>
+              </a:rPr>
+              <a:t> Elasticsearch</a:t>
+            </a:r>
+            <a:r>
+              <a:rPr lang="en-US" sz="2550" dirty="0" spc="-18" kern="0">
+                <a:solidFill>
+                  <a:srgbClr val="F3EEE3"/>
+                </a:solidFill>
+                <a:latin typeface="Be Vietnam Pro" pitchFamily="34" charset="0"/>
+                <a:ea typeface="Be Vietnam Pro" pitchFamily="34" charset="-122"/>
+                <a:cs typeface="Be Vietnam Pro" pitchFamily="34" charset="-120"/>
+              </a:rPr>
+              <a:t> và</a:t>
+            </a:r>
+            <a:r>
+              <a:rPr lang="en-US" sz="2550" dirty="0" spc="-4" kern="0">
+                <a:solidFill>
+                  <a:srgbClr val="F3EEE3"/>
+                </a:solidFill>
+                <a:latin typeface="Be Vietnam Pro" pitchFamily="34" charset="0"/>
+                <a:ea typeface="Be Vietnam Pro" pitchFamily="34" charset="-122"/>
+                <a:cs typeface="Be Vietnam Pro" pitchFamily="34" charset="-120"/>
+              </a:rPr>
+              <a:t> Kibana</a:t>
+            </a:r>
+            <a:r>
+              <a:rPr lang="en-US" sz="2550" dirty="0" spc="19" kern="0">
+                <a:solidFill>
+                  <a:srgbClr val="F3EEE3"/>
+                </a:solidFill>
+                <a:latin typeface="Be Vietnam Pro" pitchFamily="34" charset="0"/>
+                <a:ea typeface="Be Vietnam Pro" pitchFamily="34" charset="-122"/>
+                <a:cs typeface="Be Vietnam Pro" pitchFamily="34" charset="-120"/>
+              </a:rPr>
+              <a:t> để</a:t>
+            </a:r>
+            <a:r>
+              <a:rPr lang="en-US" sz="2550" dirty="0" spc="0" kern="0">
+                <a:solidFill>
+                  <a:srgbClr val="F3EEE3"/>
+                </a:solidFill>
+                <a:latin typeface="Be Vietnam Pro" pitchFamily="34" charset="0"/>
+                <a:ea typeface="Be Vietnam Pro" pitchFamily="34" charset="-122"/>
+                <a:cs typeface="Be Vietnam Pro" pitchFamily="34" charset="-120"/>
+              </a:rPr>
+              <a:t> dò</a:t>
+            </a:r>
+            <a:r>
+              <a:rPr lang="en-US" sz="2550" dirty="0" spc="-4" kern="0">
+                <a:solidFill>
+                  <a:srgbClr val="F3EEE3"/>
+                </a:solidFill>
+                <a:latin typeface="Be Vietnam Pro" pitchFamily="34" charset="0"/>
+                <a:ea typeface="Be Vietnam Pro" pitchFamily="34" charset="-122"/>
+                <a:cs typeface="Be Vietnam Pro" pitchFamily="34" charset="-120"/>
+              </a:rPr>
+              <a:t> sự</a:t>
+            </a:r>
+            <a:r>
+              <a:rPr lang="en-US" sz="2550" dirty="0" spc="0" kern="0">
+                <a:solidFill>
+                  <a:srgbClr val="F3EEE3"/>
+                </a:solidFill>
+                <a:latin typeface="Be Vietnam Pro" pitchFamily="34" charset="0"/>
+                <a:ea typeface="Be Vietnam Pro" pitchFamily="34" charset="-122"/>
+                <a:cs typeface="Be Vietnam Pro" pitchFamily="34" charset="-120"/>
+              </a:rPr>
+              <a:t> cố</a:t>
+            </a:r>
+            <a:r>
+              <a:rPr lang="en-US" sz="2550" dirty="0" spc="-1" kern="0">
+                <a:solidFill>
+                  <a:srgbClr val="F3EEE3"/>
+                </a:solidFill>
+                <a:latin typeface="Be Vietnam Pro" pitchFamily="34" charset="0"/>
+                <a:ea typeface="Be Vietnam Pro" pitchFamily="34" charset="-122"/>
+                <a:cs typeface="Be Vietnam Pro" pitchFamily="34" charset="-120"/>
+              </a:rPr>
+              <a:t> an</a:t>
+            </a:r>
+            <a:r>
+              <a:rPr lang="en-US" sz="2550" dirty="0" spc="0" kern="0">
+                <a:solidFill>
+                  <a:srgbClr val="F3EEE3"/>
+                </a:solidFill>
+                <a:latin typeface="Be Vietnam Pro" pitchFamily="34" charset="0"/>
+                <a:ea typeface="Be Vietnam Pro" pitchFamily="34" charset="-122"/>
+                <a:cs typeface="Be Vietnam Pro" pitchFamily="34" charset="-120"/>
+              </a:rPr>
+              <a:t> ninh.</a:t>
+            </a:r>
+            <a:endParaRPr lang="en-US" sz="2550" dirty="0"/>
+          </a:p>
+        </p:txBody>
+      </p:sp>
+      <p:sp>
+        <p:nvSpPr>
+          <p:cNvPr id="13" name="Shape 11"/>
+          <p:cNvSpPr/>
+          <p:nvPr/>
+        </p:nvSpPr>
+        <p:spPr>
+          <a:xfrm>
+            <a:off x="933450" y="9429750"/>
+            <a:ext cx="114300" cy="114300"/>
+          </a:xfrm>
+          <a:prstGeom prst="ellipse">
+            <a:avLst/>
+          </a:prstGeom>
+          <a:solidFill>
+            <a:srgbClr val="F3EEE3"/>
+          </a:solidFill>
+          <a:ln w="19050">
+            <a:solidFill>
+              <a:srgbClr val="F3EEE3"/>
+            </a:solidFill>
+            <a:prstDash val="solid"/>
+          </a:ln>
+        </p:spPr>
+      </p:sp>
+      <p:sp>
+        <p:nvSpPr>
+          <p:cNvPr id="14" name="Shape 12"/>
+          <p:cNvSpPr/>
+          <p:nvPr/>
+        </p:nvSpPr>
+        <p:spPr>
+          <a:xfrm>
+            <a:off x="1262063" y="9429750"/>
+            <a:ext cx="114300" cy="114300"/>
+          </a:xfrm>
+          <a:prstGeom prst="ellipse">
+            <a:avLst/>
+          </a:prstGeom>
+          <a:solidFill>
+            <a:srgbClr val="F3EEE3"/>
+          </a:solidFill>
+          <a:ln w="19050">
+            <a:solidFill>
+              <a:srgbClr val="F3EEE3"/>
+            </a:solidFill>
+            <a:prstDash val="solid"/>
+          </a:ln>
+        </p:spPr>
+      </p:sp>
+      <p:sp>
+        <p:nvSpPr>
+          <p:cNvPr id="15" name="Shape 13"/>
+          <p:cNvSpPr/>
+          <p:nvPr/>
+        </p:nvSpPr>
+        <p:spPr>
+          <a:xfrm>
+            <a:off x="1590675" y="9429750"/>
+            <a:ext cx="114300" cy="114300"/>
+          </a:xfrm>
+          <a:prstGeom prst="ellipse">
+            <a:avLst/>
+          </a:prstGeom>
+          <a:solidFill>
+            <a:srgbClr val="F3EEE3"/>
+          </a:solidFill>
+          <a:ln w="19050">
+            <a:solidFill>
+              <a:srgbClr val="F3EEE3"/>
+            </a:solidFill>
+            <a:prstDash val="solid"/>
+          </a:ln>
+        </p:spPr>
+      </p:sp>
+      <p:sp>
+        <p:nvSpPr>
+          <p:cNvPr id="16" name="Shape 14"/>
+          <p:cNvSpPr/>
+          <p:nvPr/>
+        </p:nvSpPr>
+        <p:spPr>
+          <a:xfrm>
+            <a:off x="1919288" y="9429750"/>
+            <a:ext cx="114300" cy="114300"/>
+          </a:xfrm>
+          <a:prstGeom prst="ellipse">
+            <a:avLst/>
+          </a:prstGeom>
+          <a:solidFill>
+            <a:srgbClr val="F3EEE3"/>
+          </a:solidFill>
+          <a:ln w="19050">
+            <a:solidFill>
+              <a:srgbClr val="F3EEE3"/>
+            </a:solidFill>
+            <a:prstDash val="solid"/>
+          </a:ln>
+        </p:spPr>
+      </p:sp>
+      <p:sp>
+        <p:nvSpPr>
+          <p:cNvPr id="17" name="Shape 15"/>
+          <p:cNvSpPr/>
+          <p:nvPr/>
+        </p:nvSpPr>
+        <p:spPr>
+          <a:xfrm>
+            <a:off x="2247900" y="9429750"/>
+            <a:ext cx="114300" cy="114300"/>
+          </a:xfrm>
+          <a:prstGeom prst="ellipse">
+            <a:avLst/>
+          </a:prstGeom>
+          <a:solidFill>
+            <a:srgbClr val="F3EEE3"/>
+          </a:solidFill>
+          <a:ln w="19050">
+            <a:solidFill>
+              <a:srgbClr val="F3EEE3"/>
+            </a:solidFill>
+            <a:prstDash val="solid"/>
+          </a:ln>
+        </p:spPr>
+      </p:sp>
+      <p:sp>
+        <p:nvSpPr>
+          <p:cNvPr id="18" name="Shape 16"/>
+          <p:cNvSpPr/>
+          <p:nvPr/>
+        </p:nvSpPr>
+        <p:spPr>
+          <a:xfrm>
+            <a:off x="2528888" y="9382125"/>
+            <a:ext cx="209550" cy="209550"/>
+          </a:xfrm>
+          <a:prstGeom prst="ellipse">
+            <a:avLst/>
+          </a:prstGeom>
+          <a:solidFill>
+            <a:srgbClr val="FF6A4D"/>
+          </a:solidFill>
+          <a:ln w="19050">
+            <a:solidFill>
+              <a:srgbClr val="FF6A4D"/>
+            </a:solidFill>
+            <a:prstDash val="solid"/>
+          </a:ln>
+        </p:spPr>
+      </p:sp>
+      <p:sp>
+        <p:nvSpPr>
+          <p:cNvPr id="19" name="Shape 17"/>
+          <p:cNvSpPr/>
+          <p:nvPr/>
+        </p:nvSpPr>
+        <p:spPr>
+          <a:xfrm>
+            <a:off x="2905125" y="9429750"/>
+            <a:ext cx="114300" cy="114300"/>
+          </a:xfrm>
+          <a:prstGeom prst="ellipse">
+            <a:avLst/>
+          </a:prstGeom>
+          <a:solidFill>
+            <a:srgbClr val="14161C"/>
+          </a:solidFill>
+          <a:ln w="19050">
+            <a:solidFill>
+              <a:srgbClr val="F3EEE3"/>
+            </a:solidFill>
+            <a:prstDash val="solid"/>
+          </a:ln>
+        </p:spPr>
+      </p:sp>
+      <p:sp>
+        <p:nvSpPr>
+          <p:cNvPr id="20" name="Shape 18"/>
+          <p:cNvSpPr/>
+          <p:nvPr/>
+        </p:nvSpPr>
+        <p:spPr>
+          <a:xfrm>
+            <a:off x="3233738" y="9429750"/>
+            <a:ext cx="114300" cy="114300"/>
+          </a:xfrm>
+          <a:prstGeom prst="ellipse">
+            <a:avLst/>
+          </a:prstGeom>
+          <a:solidFill>
+            <a:srgbClr val="14161C"/>
+          </a:solidFill>
+          <a:ln w="19050">
+            <a:solidFill>
+              <a:srgbClr val="F3EEE3"/>
+            </a:solidFill>
+            <a:prstDash val="solid"/>
+          </a:ln>
+        </p:spPr>
+      </p:sp>
+      <p:sp>
+        <p:nvSpPr>
+          <p:cNvPr id="21" name="Shape 19"/>
+          <p:cNvSpPr/>
+          <p:nvPr/>
+        </p:nvSpPr>
+        <p:spPr>
+          <a:xfrm>
+            <a:off x="3562350" y="9429750"/>
+            <a:ext cx="114300" cy="114300"/>
+          </a:xfrm>
+          <a:prstGeom prst="ellipse">
+            <a:avLst/>
+          </a:prstGeom>
+          <a:solidFill>
+            <a:srgbClr val="14161C"/>
+          </a:solidFill>
+          <a:ln w="19050">
+            <a:solidFill>
+              <a:srgbClr val="F3EEE3"/>
+            </a:solidFill>
+            <a:prstDash val="solid"/>
+          </a:ln>
+        </p:spPr>
+      </p:sp>
+      <p:sp>
+        <p:nvSpPr>
+          <p:cNvPr id="22" name="Shape 20"/>
+          <p:cNvSpPr/>
+          <p:nvPr/>
+        </p:nvSpPr>
+        <p:spPr>
+          <a:xfrm>
+            <a:off x="3890962" y="9429750"/>
+            <a:ext cx="114300" cy="114300"/>
+          </a:xfrm>
+          <a:prstGeom prst="ellipse">
+            <a:avLst/>
+          </a:prstGeom>
+          <a:solidFill>
+            <a:srgbClr val="14161C"/>
+          </a:solidFill>
+          <a:ln w="19050">
+            <a:solidFill>
+              <a:srgbClr val="F3EEE3"/>
+            </a:solidFill>
+            <a:prstDash val="solid"/>
+          </a:ln>
+        </p:spPr>
+      </p:sp>
+      <p:sp>
+        <p:nvSpPr>
+          <p:cNvPr id="23" name="Text 21"/>
+          <p:cNvSpPr/>
+          <p:nvPr/>
+        </p:nvSpPr>
+        <p:spPr>
+          <a:xfrm>
+            <a:off x="914400" y="9715500"/>
+            <a:ext cx="7620000" cy="285750"/>
+          </a:xfrm>
+          <a:prstGeom prst="rect">
+            <a:avLst/>
+          </a:prstGeom>
+          <a:noFill/>
+          <a:ln/>
+        </p:spPr>
+        <p:txBody>
+          <a:bodyPr wrap="square" lIns="0" tIns="0" rIns="0" bIns="0" rtlCol="0" anchor="t"/>
+          <a:lstStyle/>
+          <a:p>
+            <a:pPr algn="l" indent="0" marL="0">
+              <a:buNone/>
+            </a:pPr>
+            <a:r>
               <a:rPr lang="en-US" sz="1650" dirty="0" spc="-12" kern="0">
                 <a:solidFill>
                   <a:srgbClr val="9A98A0"/>
@@ -11839,7 +12060,7 @@
       </p:sp>
       <p:sp>
         <p:nvSpPr>
-          <p:cNvPr id="21" name="Shape 19"/>
+          <p:cNvPr id="24" name="Shape 22"/>
           <p:cNvSpPr/>
           <p:nvPr/>
         </p:nvSpPr>
@@ -11863,7 +12084,7 @@
       </p:sp>
       <p:pic>
         <p:nvPicPr>
-          <p:cNvPr id="22" name="Moda image moda-export-watermark-e59a11be-8b32-46be-8f30-c30970005757" descr="">    </p:cNvPr>
+          <p:cNvPr id="25" name="Moda image moda-export-watermark-e59a11be-8b32-46be-8f30-c30970005757" descr="">    </p:cNvPr>
           <p:cNvPicPr>
             <a:picLocks noChangeAspect="1"/>
           </p:cNvPicPr>

</xml_diff>